<commit_message>
Slajd 2 dla ARiMR: wspólny zespół (role po obu stronach) i harmonogram pilotażu
Co-Authored-By: Claude Opus 5.5 <noreply@anthropic.com>
Claude-Session: https://claude.ai/code/session_013zBoiULUmuAAompFubq5tx
</commit_message>
<xml_diff>
--- a/GA_GAia_ARiMR_integracja.pptx
+++ b/GA_GAia_ARiMR_integracja.pptx
@@ -6,9 +6,10 @@
   </p:sldMasterIdLst>
   <p:sldIdLst>
     <p:sldId id="256" r:id="rId2"/>
+    <p:sldId id="257" r:id="rId3"/>
   </p:sldIdLst>
   <p:notesMasterIdLst>
-    <p:notesMasterId r:id="rId3"/>
+    <p:notesMasterId r:id="rId4"/>
   </p:notesMasterIdLst>
   <p:sldSz cx="9144000" cy="5143500"/>
   <p:notesSz cx="5143500" cy="9144000"/>
@@ -549,6 +550,98 @@
 </p:notes>
 </file>
 
+<file path=ppt/notesSlides/notesSlide2.xml><?xml version="1.0" encoding="utf-8"?>
+<p:notes xmlns:a="http://schemas.openxmlformats.org/drawingml/2006/main" xmlns:r="http://schemas.openxmlformats.org/officeDocument/2006/relationships" xmlns:p="http://schemas.openxmlformats.org/presentationml/2006/main">
+  <p:cSld>
+    <p:spTree>
+      <p:nvGrpSpPr>
+        <p:cNvPr id="1" name=""/>
+        <p:cNvGrpSpPr/>
+        <p:nvPr/>
+      </p:nvGrpSpPr>
+      <p:grpSpPr>
+        <a:xfrm>
+          <a:off x="0" y="0"/>
+          <a:ext cx="0" cy="0"/>
+          <a:chOff x="0" y="0"/>
+          <a:chExt cx="0" cy="0"/>
+        </a:xfrm>
+      </p:grpSpPr>
+      <p:sp>
+        <p:nvSpPr>
+          <p:cNvPr id="2" name="Slide Image Placeholder 1"/>
+          <p:cNvSpPr>
+            <a:spLocks noGrp="1" noRot="1" noChangeAspect="1"/>
+          </p:cNvSpPr>
+          <p:nvPr>
+            <p:ph type="sldImg"/>
+          </p:nvPr>
+        </p:nvSpPr>
+        <p:spPr/>
+      </p:sp>
+      <p:sp>
+        <p:nvSpPr>
+          <p:cNvPr id="3" name="Notes Placeholder 2"/>
+          <p:cNvSpPr>
+            <a:spLocks noGrp="1"/>
+          </p:cNvSpPr>
+          <p:nvPr>
+            <p:ph type="body" idx="1"/>
+          </p:nvPr>
+        </p:nvSpPr>
+        <p:spPr/>
+        <p:txBody>
+          <a:bodyPr/>
+          <a:lstStyle/>
+          <a:p>
+            <a:r>
+              <a:rPr lang="en-US" dirty="0"/>
+              <a:t>Żeby porozumienie nie zostało na papierze, proponujemy mały wspólny zespół. Każda rola ma swój odpowiednik po obu stronach.
+Sponsorzy podejmują decyzje raz w miesiącu. Koordynatorzy prowadzą plan i spotykają się co tydzień. Technicy opisują usługę, przez którą ARiMR odda dane rolnika po jego zgodzie, i testują ją na danych testowych. Prawnicy i inspektorzy ochrony danych uzgadniają treść zgody i umowę o udostępnianiu danych. Koordynator agronomów i biuro ARiMR w województwie pilotażowym zbierają rolników do testu.
+Po naszej stronie to osiem osób, po stronie ARiMR sześć, wszyscy na część etatu.
+Harmonogram: do 23 października wskazujemy osoby i robimy spotkanie startowe. W listopadzie zakres danych, treść zgody i umowa wykonawcza. Grudzień i styczeń to usługa i testy. Od lutego do kwietnia pilotaż w jednym województwie, w sezonie wiosennym. W maju wyniki i decyzja o całym kraju.
+Dziś prosimy o koordynatora i pięć osób do zespołu do 23 października oraz dokumentację systemu i dostęp do środowiska testowego.</a:t>
+            </a:r>
+            <a:endParaRPr lang="en-US" dirty="0"/>
+          </a:p>
+        </p:txBody>
+      </p:sp>
+      <p:sp>
+        <p:nvSpPr>
+          <p:cNvPr id="4" name="Slide Number Placeholder 3"/>
+          <p:cNvSpPr>
+            <a:spLocks noGrp="1"/>
+          </p:cNvSpPr>
+          <p:nvPr>
+            <p:ph type="sldNum" sz="quarter" idx="10"/>
+          </p:nvPr>
+        </p:nvSpPr>
+        <p:spPr/>
+        <p:txBody>
+          <a:bodyPr/>
+          <a:lstStyle/>
+          <a:p>
+            <a:fld id="{F7021451-1387-4CA6-816F-3879F97B5CBC}" type="slidenum">
+              <a:rPr lang="en-US"/>
+              <a:t>2</a:t>
+            </a:fld>
+            <a:endParaRPr lang="en-US"/>
+          </a:p>
+        </p:txBody>
+      </p:sp>
+    </p:spTree>
+    <p:extLst>
+      <p:ext uri="{BB962C8B-B14F-4D97-AF65-F5344CB8AC3E}">
+        <p14:creationId xmlns:p14="http://schemas.microsoft.com/office/powerpoint/2010/main" val="1024086991"/>
+      </p:ext>
+    </p:extLst>
+  </p:cSld>
+  <p:clrMapOvr>
+    <a:masterClrMapping/>
+  </p:clrMapOvr>
+</p:notes>
+</file>
+
 <file path=ppt/slideLayouts/slideLayout1.xml><?xml version="1.0" encoding="utf-8"?>
 <p:sldLayout xmlns:a="http://schemas.openxmlformats.org/drawingml/2006/main" xmlns:r="http://schemas.openxmlformats.org/officeDocument/2006/relationships" xmlns:p="http://schemas.openxmlformats.org/presentationml/2006/main" preserve="1">
   <p:cSld name="DEFAULT">
@@ -2640,6 +2733,2288 @@
                 <a:cs typeface="Arial" pitchFamily="34" charset="-120"/>
               </a:rPr>
               <a:t>wspólny zespół techniczny i pilotaż integracji.</a:t>
+            </a:r>
+            <a:endParaRPr lang="en-US" sz="1000" dirty="0"/>
+          </a:p>
+        </p:txBody>
+      </p:sp>
+    </p:spTree>
+  </p:cSld>
+  <p:clrMapOvr>
+    <a:masterClrMapping/>
+  </p:clrMapOvr>
+</p:sld>
+</file>
+
+<file path=ppt/slides/slide2.xml><?xml version="1.0" encoding="utf-8"?>
+<p:sld xmlns:a="http://schemas.openxmlformats.org/drawingml/2006/main" xmlns:r="http://schemas.openxmlformats.org/officeDocument/2006/relationships" xmlns:p="http://schemas.openxmlformats.org/presentationml/2006/main">
+  <p:cSld name="Slide 2">
+    <p:bg>
+      <p:bgPr>
+        <a:blipFill dpi="0" rotWithShape="1">
+          <a:blip r:embed="rId1">
+            <a:lum/>
+          </a:blip>
+          <a:srcRect/>
+          <a:stretch>
+            <a:fillRect/>
+          </a:stretch>
+        </a:blipFill>
+        <a:effectLst/>
+      </p:bgPr>
+    </p:bg>
+    <p:spTree>
+      <p:nvGrpSpPr>
+        <p:cNvPr id="1" name=""/>
+        <p:cNvGrpSpPr/>
+        <p:nvPr/>
+      </p:nvGrpSpPr>
+      <p:grpSpPr>
+        <a:xfrm>
+          <a:off x="0" y="0"/>
+          <a:ext cx="0" cy="0"/>
+          <a:chOff x="0" y="0"/>
+          <a:chExt cx="0" cy="0"/>
+        </a:xfrm>
+      </p:grpSpPr>
+      <p:sp>
+        <p:nvSpPr>
+          <p:cNvPr id="2" name="Text 0"/>
+          <p:cNvSpPr txBox="1"/>
+          <p:nvPr/>
+        </p:nvSpPr>
+        <p:spPr>
+          <a:xfrm>
+            <a:off x="365760" y="164592"/>
+            <a:ext cx="8412480" cy="457200"/>
+          </a:xfrm>
+          <a:prstGeom prst="rect">
+            <a:avLst/>
+          </a:prstGeom>
+          <a:noFill/>
+          <a:ln/>
+        </p:spPr>
+        <p:txBody>
+          <a:bodyPr wrap="square" lIns="0" tIns="0" rIns="0" bIns="0" rtlCol="0" anchor="ctr"/>
+          <a:lstStyle/>
+          <a:p>
+            <a:pPr algn="ctr" indent="0" marL="0">
+              <a:buNone/>
+            </a:pPr>
+            <a:r>
+              <a:rPr lang="en-US" sz="2400" b="1" dirty="0">
+                <a:solidFill>
+                  <a:srgbClr val="2B2B2B"/>
+                </a:solidFill>
+                <a:latin typeface="Arial" pitchFamily="34" charset="0"/>
+                <a:ea typeface="Arial" pitchFamily="34" charset="-122"/>
+                <a:cs typeface="Arial" pitchFamily="34" charset="-120"/>
+              </a:rPr>
+              <a:t>WSPÓLNY ZESPÓŁ I PILOTAŻ: KTO, CO, KIEDY</a:t>
+            </a:r>
+            <a:endParaRPr lang="en-US" sz="2400" dirty="0"/>
+          </a:p>
+        </p:txBody>
+      </p:sp>
+      <p:sp>
+        <p:nvSpPr>
+          <p:cNvPr id="3" name="Text 1"/>
+          <p:cNvSpPr txBox="1"/>
+          <p:nvPr/>
+        </p:nvSpPr>
+        <p:spPr>
+          <a:xfrm>
+            <a:off x="365760" y="640080"/>
+            <a:ext cx="8412480" cy="274320"/>
+          </a:xfrm>
+          <a:prstGeom prst="rect">
+            <a:avLst/>
+          </a:prstGeom>
+          <a:noFill/>
+          <a:ln/>
+        </p:spPr>
+        <p:txBody>
+          <a:bodyPr wrap="square" lIns="0" tIns="0" rIns="0" bIns="0" rtlCol="0" anchor="ctr"/>
+          <a:lstStyle/>
+          <a:p>
+            <a:pPr algn="ctr" indent="0" marL="0">
+              <a:buNone/>
+            </a:pPr>
+            <a:r>
+              <a:rPr lang="en-US" sz="1100" dirty="0">
+                <a:solidFill>
+                  <a:srgbClr val="2B2B2B"/>
+                </a:solidFill>
+                <a:latin typeface="Arial" pitchFamily="34" charset="0"/>
+                <a:ea typeface="Arial" pitchFamily="34" charset="-122"/>
+                <a:cs typeface="Arial" pitchFamily="34" charset="-120"/>
+              </a:rPr>
+              <a:t>Propozycja: 8 osób po naszej stronie, 6 po stronie ARiMR (część etatu). Zespół co tydzień, komitet raz w miesiącu.</a:t>
+            </a:r>
+            <a:endParaRPr lang="en-US" sz="1100" dirty="0"/>
+          </a:p>
+        </p:txBody>
+      </p:sp>
+      <p:sp>
+        <p:nvSpPr>
+          <p:cNvPr id="4" name="Shape 2"/>
+          <p:cNvSpPr/>
+          <p:nvPr/>
+        </p:nvSpPr>
+        <p:spPr>
+          <a:xfrm>
+            <a:off x="457200" y="1005840"/>
+            <a:ext cx="3154680" cy="292608"/>
+          </a:xfrm>
+          <a:prstGeom prst="roundRect">
+            <a:avLst>
+              <a:gd name="adj" fmla="val 15625"/>
+            </a:avLst>
+          </a:prstGeom>
+          <a:solidFill>
+            <a:srgbClr val="2B2B2B"/>
+          </a:solidFill>
+          <a:ln w="12700">
+            <a:solidFill>
+              <a:srgbClr val="2B2B2B"/>
+            </a:solidFill>
+            <a:prstDash val="solid"/>
+          </a:ln>
+        </p:spPr>
+      </p:sp>
+      <p:sp>
+        <p:nvSpPr>
+          <p:cNvPr id="5" name="Text 3"/>
+          <p:cNvSpPr txBox="1"/>
+          <p:nvPr/>
+        </p:nvSpPr>
+        <p:spPr>
+          <a:xfrm>
+            <a:off x="457200" y="1005840"/>
+            <a:ext cx="3154680" cy="292608"/>
+          </a:xfrm>
+          <a:prstGeom prst="rect">
+            <a:avLst/>
+          </a:prstGeom>
+          <a:noFill/>
+          <a:ln/>
+        </p:spPr>
+        <p:txBody>
+          <a:bodyPr wrap="square" lIns="0" tIns="0" rIns="0" bIns="0" rtlCol="0" anchor="ctr"/>
+          <a:lstStyle/>
+          <a:p>
+            <a:pPr algn="ctr" indent="0" marL="0">
+              <a:buNone/>
+            </a:pPr>
+            <a:r>
+              <a:rPr lang="en-US" sz="900" b="1" spc="150" kern="0" dirty="0">
+                <a:solidFill>
+                  <a:srgbClr val="FFFFFF"/>
+                </a:solidFill>
+                <a:latin typeface="Arial" pitchFamily="34" charset="0"/>
+                <a:ea typeface="Arial" pitchFamily="34" charset="-122"/>
+                <a:cs typeface="Arial" pitchFamily="34" charset="-120"/>
+              </a:rPr>
+              <a:t>PO NASZEJ STRONIE: GAia</a:t>
+            </a:r>
+            <a:endParaRPr lang="en-US" sz="900" dirty="0"/>
+          </a:p>
+        </p:txBody>
+      </p:sp>
+      <p:sp>
+        <p:nvSpPr>
+          <p:cNvPr id="6" name="Shape 4"/>
+          <p:cNvSpPr/>
+          <p:nvPr/>
+        </p:nvSpPr>
+        <p:spPr>
+          <a:xfrm>
+            <a:off x="3749040" y="1005840"/>
+            <a:ext cx="1645920" cy="292608"/>
+          </a:xfrm>
+          <a:prstGeom prst="roundRect">
+            <a:avLst>
+              <a:gd name="adj" fmla="val 15625"/>
+            </a:avLst>
+          </a:prstGeom>
+          <a:solidFill>
+            <a:srgbClr val="2E7D4F"/>
+          </a:solidFill>
+          <a:ln w="12700">
+            <a:solidFill>
+              <a:srgbClr val="2E7D4F"/>
+            </a:solidFill>
+            <a:prstDash val="solid"/>
+          </a:ln>
+        </p:spPr>
+      </p:sp>
+      <p:sp>
+        <p:nvSpPr>
+          <p:cNvPr id="7" name="Text 5"/>
+          <p:cNvSpPr txBox="1"/>
+          <p:nvPr/>
+        </p:nvSpPr>
+        <p:spPr>
+          <a:xfrm>
+            <a:off x="3749040" y="1005840"/>
+            <a:ext cx="1645920" cy="292608"/>
+          </a:xfrm>
+          <a:prstGeom prst="rect">
+            <a:avLst/>
+          </a:prstGeom>
+          <a:noFill/>
+          <a:ln/>
+        </p:spPr>
+        <p:txBody>
+          <a:bodyPr wrap="square" lIns="0" tIns="0" rIns="0" bIns="0" rtlCol="0" anchor="ctr"/>
+          <a:lstStyle/>
+          <a:p>
+            <a:pPr algn="ctr" indent="0" marL="0">
+              <a:buNone/>
+            </a:pPr>
+            <a:r>
+              <a:rPr lang="en-US" sz="900" b="1" spc="150" kern="0" dirty="0">
+                <a:solidFill>
+                  <a:srgbClr val="FFFFFF"/>
+                </a:solidFill>
+                <a:latin typeface="Arial" pitchFamily="34" charset="0"/>
+                <a:ea typeface="Arial" pitchFamily="34" charset="-122"/>
+                <a:cs typeface="Arial" pitchFamily="34" charset="-120"/>
+              </a:rPr>
+              <a:t>WSPÓLNIE</a:t>
+            </a:r>
+            <a:endParaRPr lang="en-US" sz="900" dirty="0"/>
+          </a:p>
+        </p:txBody>
+      </p:sp>
+      <p:sp>
+        <p:nvSpPr>
+          <p:cNvPr id="8" name="Shape 6"/>
+          <p:cNvSpPr/>
+          <p:nvPr/>
+        </p:nvSpPr>
+        <p:spPr>
+          <a:xfrm>
+            <a:off x="5532120" y="1005840"/>
+            <a:ext cx="3154680" cy="292608"/>
+          </a:xfrm>
+          <a:prstGeom prst="roundRect">
+            <a:avLst>
+              <a:gd name="adj" fmla="val 15625"/>
+            </a:avLst>
+          </a:prstGeom>
+          <a:solidFill>
+            <a:srgbClr val="2E5F8A"/>
+          </a:solidFill>
+          <a:ln w="12700">
+            <a:solidFill>
+              <a:srgbClr val="2E5F8A"/>
+            </a:solidFill>
+            <a:prstDash val="solid"/>
+          </a:ln>
+        </p:spPr>
+      </p:sp>
+      <p:sp>
+        <p:nvSpPr>
+          <p:cNvPr id="9" name="Text 7"/>
+          <p:cNvSpPr txBox="1"/>
+          <p:nvPr/>
+        </p:nvSpPr>
+        <p:spPr>
+          <a:xfrm>
+            <a:off x="5532120" y="1005840"/>
+            <a:ext cx="3154680" cy="292608"/>
+          </a:xfrm>
+          <a:prstGeom prst="rect">
+            <a:avLst/>
+          </a:prstGeom>
+          <a:noFill/>
+          <a:ln/>
+        </p:spPr>
+        <p:txBody>
+          <a:bodyPr wrap="square" lIns="0" tIns="0" rIns="0" bIns="0" rtlCol="0" anchor="ctr"/>
+          <a:lstStyle/>
+          <a:p>
+            <a:pPr algn="ctr" indent="0" marL="0">
+              <a:buNone/>
+            </a:pPr>
+            <a:r>
+              <a:rPr lang="en-US" sz="900" b="1" spc="150" kern="0" dirty="0">
+                <a:solidFill>
+                  <a:srgbClr val="FFFFFF"/>
+                </a:solidFill>
+                <a:latin typeface="Arial" pitchFamily="34" charset="0"/>
+                <a:ea typeface="Arial" pitchFamily="34" charset="-122"/>
+                <a:cs typeface="Arial" pitchFamily="34" charset="-120"/>
+              </a:rPr>
+              <a:t>PO STRONIE ARiMR</a:t>
+            </a:r>
+            <a:endParaRPr lang="en-US" sz="900" dirty="0"/>
+          </a:p>
+        </p:txBody>
+      </p:sp>
+      <p:sp>
+        <p:nvSpPr>
+          <p:cNvPr id="10" name="nasi0"/>
+          <p:cNvSpPr/>
+          <p:nvPr/>
+        </p:nvSpPr>
+        <p:spPr>
+          <a:xfrm>
+            <a:off x="457200" y="1389888"/>
+            <a:ext cx="3154680" cy="329184"/>
+          </a:xfrm>
+          <a:prstGeom prst="roundRect">
+            <a:avLst>
+              <a:gd name="adj" fmla="val 13889"/>
+            </a:avLst>
+          </a:prstGeom>
+          <a:solidFill>
+            <a:srgbClr val="FFFFFF"/>
+          </a:solidFill>
+          <a:ln w="12700">
+            <a:solidFill>
+              <a:srgbClr val="2B2B2B"/>
+            </a:solidFill>
+            <a:prstDash val="solid"/>
+          </a:ln>
+        </p:spPr>
+      </p:sp>
+      <p:sp>
+        <p:nvSpPr>
+          <p:cNvPr id="11" name="Text 9"/>
+          <p:cNvSpPr txBox="1"/>
+          <p:nvPr/>
+        </p:nvSpPr>
+        <p:spPr>
+          <a:xfrm>
+            <a:off x="566928" y="1389888"/>
+            <a:ext cx="2971800" cy="329184"/>
+          </a:xfrm>
+          <a:prstGeom prst="rect">
+            <a:avLst/>
+          </a:prstGeom>
+          <a:noFill/>
+          <a:ln/>
+        </p:spPr>
+        <p:txBody>
+          <a:bodyPr wrap="square" lIns="0" tIns="0" rIns="0" bIns="0" rtlCol="0" anchor="ctr"/>
+          <a:lstStyle/>
+          <a:p>
+            <a:pPr indent="0" marL="0">
+              <a:buNone/>
+            </a:pPr>
+            <a:r>
+              <a:rPr lang="en-US" sz="950" b="1" dirty="0">
+                <a:solidFill>
+                  <a:srgbClr val="2B2B2B"/>
+                </a:solidFill>
+                <a:latin typeface="Arial" pitchFamily="34" charset="0"/>
+                <a:ea typeface="Arial" pitchFamily="34" charset="-122"/>
+                <a:cs typeface="Arial" pitchFamily="34" charset="-120"/>
+              </a:rPr>
+              <a:t>Sponsor: </a:t>
+            </a:r>
+            <a:pPr indent="0" marL="0">
+              <a:buNone/>
+            </a:pPr>
+            <a:r>
+              <a:rPr lang="en-US" sz="950" dirty="0">
+                <a:solidFill>
+                  <a:srgbClr val="2B2B2B"/>
+                </a:solidFill>
+                <a:latin typeface="Arial" pitchFamily="34" charset="0"/>
+                <a:ea typeface="Arial" pitchFamily="34" charset="-122"/>
+                <a:cs typeface="Arial" pitchFamily="34" charset="-120"/>
+              </a:rPr>
+              <a:t>dyrektor programu GAia</a:t>
+            </a:r>
+            <a:endParaRPr lang="en-US" sz="950" dirty="0"/>
+          </a:p>
+        </p:txBody>
+      </p:sp>
+      <p:sp>
+        <p:nvSpPr>
+          <p:cNvPr id="12" name="wspolnie0"/>
+          <p:cNvSpPr/>
+          <p:nvPr/>
+        </p:nvSpPr>
+        <p:spPr>
+          <a:xfrm>
+            <a:off x="3749040" y="1389888"/>
+            <a:ext cx="1645920" cy="329184"/>
+          </a:xfrm>
+          <a:prstGeom prst="roundRect">
+            <a:avLst>
+              <a:gd name="adj" fmla="val 13889"/>
+            </a:avLst>
+          </a:prstGeom>
+          <a:solidFill>
+            <a:srgbClr val="E6F2EA"/>
+          </a:solidFill>
+          <a:ln w="12700">
+            <a:solidFill>
+              <a:srgbClr val="E6F2EA"/>
+            </a:solidFill>
+            <a:prstDash val="solid"/>
+          </a:ln>
+        </p:spPr>
+      </p:sp>
+      <p:sp>
+        <p:nvSpPr>
+          <p:cNvPr id="13" name="Text 11"/>
+          <p:cNvSpPr txBox="1"/>
+          <p:nvPr/>
+        </p:nvSpPr>
+        <p:spPr>
+          <a:xfrm>
+            <a:off x="3675888" y="1389888"/>
+            <a:ext cx="1792224" cy="329184"/>
+          </a:xfrm>
+          <a:prstGeom prst="rect">
+            <a:avLst/>
+          </a:prstGeom>
+          <a:noFill/>
+          <a:ln/>
+        </p:spPr>
+        <p:txBody>
+          <a:bodyPr wrap="square" lIns="0" tIns="0" rIns="0" bIns="0" rtlCol="0" anchor="ctr"/>
+          <a:lstStyle/>
+          <a:p>
+            <a:pPr algn="ctr" indent="0" marL="0">
+              <a:buNone/>
+            </a:pPr>
+            <a:r>
+              <a:rPr lang="en-US" sz="850" b="1" dirty="0">
+                <a:solidFill>
+                  <a:srgbClr val="2E7D4F"/>
+                </a:solidFill>
+                <a:latin typeface="Arial" pitchFamily="34" charset="0"/>
+                <a:ea typeface="Arial" pitchFamily="34" charset="-122"/>
+                <a:cs typeface="Arial" pitchFamily="34" charset="-120"/>
+              </a:rPr>
+              <a:t>⟵ decyzje, raz w miesiącu ⟶</a:t>
+            </a:r>
+            <a:endParaRPr lang="en-US" sz="850" dirty="0"/>
+          </a:p>
+        </p:txBody>
+      </p:sp>
+      <p:sp>
+        <p:nvSpPr>
+          <p:cNvPr id="14" name="arimr0"/>
+          <p:cNvSpPr/>
+          <p:nvPr/>
+        </p:nvSpPr>
+        <p:spPr>
+          <a:xfrm>
+            <a:off x="5532120" y="1389888"/>
+            <a:ext cx="3154680" cy="329184"/>
+          </a:xfrm>
+          <a:prstGeom prst="roundRect">
+            <a:avLst>
+              <a:gd name="adj" fmla="val 13889"/>
+            </a:avLst>
+          </a:prstGeom>
+          <a:solidFill>
+            <a:srgbClr val="EAF1F8"/>
+          </a:solidFill>
+          <a:ln w="12700">
+            <a:solidFill>
+              <a:srgbClr val="2E5F8A"/>
+            </a:solidFill>
+            <a:prstDash val="solid"/>
+          </a:ln>
+        </p:spPr>
+      </p:sp>
+      <p:sp>
+        <p:nvSpPr>
+          <p:cNvPr id="15" name="Text 13"/>
+          <p:cNvSpPr txBox="1"/>
+          <p:nvPr/>
+        </p:nvSpPr>
+        <p:spPr>
+          <a:xfrm>
+            <a:off x="5641848" y="1389888"/>
+            <a:ext cx="2971800" cy="329184"/>
+          </a:xfrm>
+          <a:prstGeom prst="rect">
+            <a:avLst/>
+          </a:prstGeom>
+          <a:noFill/>
+          <a:ln/>
+        </p:spPr>
+        <p:txBody>
+          <a:bodyPr wrap="square" lIns="0" tIns="0" rIns="0" bIns="0" rtlCol="0" anchor="ctr"/>
+          <a:lstStyle/>
+          <a:p>
+            <a:pPr indent="0" marL="0">
+              <a:buNone/>
+            </a:pPr>
+            <a:r>
+              <a:rPr lang="en-US" sz="950" b="1" dirty="0">
+                <a:solidFill>
+                  <a:srgbClr val="2B2B2B"/>
+                </a:solidFill>
+                <a:latin typeface="Arial" pitchFamily="34" charset="0"/>
+                <a:ea typeface="Arial" pitchFamily="34" charset="-122"/>
+                <a:cs typeface="Arial" pitchFamily="34" charset="-120"/>
+              </a:rPr>
+              <a:t>Sponsor: </a:t>
+            </a:r>
+            <a:pPr indent="0" marL="0">
+              <a:buNone/>
+            </a:pPr>
+            <a:r>
+              <a:rPr lang="en-US" sz="950" dirty="0">
+                <a:solidFill>
+                  <a:srgbClr val="2B2B2B"/>
+                </a:solidFill>
+                <a:latin typeface="Arial" pitchFamily="34" charset="0"/>
+                <a:ea typeface="Arial" pitchFamily="34" charset="-122"/>
+                <a:cs typeface="Arial" pitchFamily="34" charset="-120"/>
+              </a:rPr>
+              <a:t>dyrektor właściwego departamentu</a:t>
+            </a:r>
+            <a:endParaRPr lang="en-US" sz="950" dirty="0"/>
+          </a:p>
+        </p:txBody>
+      </p:sp>
+      <p:sp>
+        <p:nvSpPr>
+          <p:cNvPr id="16" name="nasi1"/>
+          <p:cNvSpPr/>
+          <p:nvPr/>
+        </p:nvSpPr>
+        <p:spPr>
+          <a:xfrm>
+            <a:off x="457200" y="1783080"/>
+            <a:ext cx="3154680" cy="329184"/>
+          </a:xfrm>
+          <a:prstGeom prst="roundRect">
+            <a:avLst>
+              <a:gd name="adj" fmla="val 13889"/>
+            </a:avLst>
+          </a:prstGeom>
+          <a:solidFill>
+            <a:srgbClr val="FFFFFF"/>
+          </a:solidFill>
+          <a:ln w="12700">
+            <a:solidFill>
+              <a:srgbClr val="2B2B2B"/>
+            </a:solidFill>
+            <a:prstDash val="solid"/>
+          </a:ln>
+        </p:spPr>
+      </p:sp>
+      <p:sp>
+        <p:nvSpPr>
+          <p:cNvPr id="17" name="Text 15"/>
+          <p:cNvSpPr txBox="1"/>
+          <p:nvPr/>
+        </p:nvSpPr>
+        <p:spPr>
+          <a:xfrm>
+            <a:off x="566928" y="1783080"/>
+            <a:ext cx="2971800" cy="329184"/>
+          </a:xfrm>
+          <a:prstGeom prst="rect">
+            <a:avLst/>
+          </a:prstGeom>
+          <a:noFill/>
+          <a:ln/>
+        </p:spPr>
+        <p:txBody>
+          <a:bodyPr wrap="square" lIns="0" tIns="0" rIns="0" bIns="0" rtlCol="0" anchor="ctr"/>
+          <a:lstStyle/>
+          <a:p>
+            <a:pPr indent="0" marL="0">
+              <a:buNone/>
+            </a:pPr>
+            <a:r>
+              <a:rPr lang="en-US" sz="950" b="1" dirty="0">
+                <a:solidFill>
+                  <a:srgbClr val="2B2B2B"/>
+                </a:solidFill>
+                <a:latin typeface="Arial" pitchFamily="34" charset="0"/>
+                <a:ea typeface="Arial" pitchFamily="34" charset="-122"/>
+                <a:cs typeface="Arial" pitchFamily="34" charset="-120"/>
+              </a:rPr>
+              <a:t>Koordynator: </a:t>
+            </a:r>
+            <a:pPr indent="0" marL="0">
+              <a:buNone/>
+            </a:pPr>
+            <a:r>
+              <a:rPr lang="en-US" sz="950" dirty="0">
+                <a:solidFill>
+                  <a:srgbClr val="2B2B2B"/>
+                </a:solidFill>
+                <a:latin typeface="Arial" pitchFamily="34" charset="0"/>
+                <a:ea typeface="Arial" pitchFamily="34" charset="-122"/>
+                <a:cs typeface="Arial" pitchFamily="34" charset="-120"/>
+              </a:rPr>
+              <a:t>kierownik projektu GAia</a:t>
+            </a:r>
+            <a:endParaRPr lang="en-US" sz="950" dirty="0"/>
+          </a:p>
+        </p:txBody>
+      </p:sp>
+      <p:sp>
+        <p:nvSpPr>
+          <p:cNvPr id="18" name="wspolnie1"/>
+          <p:cNvSpPr/>
+          <p:nvPr/>
+        </p:nvSpPr>
+        <p:spPr>
+          <a:xfrm>
+            <a:off x="3749040" y="1783080"/>
+            <a:ext cx="1645920" cy="329184"/>
+          </a:xfrm>
+          <a:prstGeom prst="roundRect">
+            <a:avLst>
+              <a:gd name="adj" fmla="val 13889"/>
+            </a:avLst>
+          </a:prstGeom>
+          <a:solidFill>
+            <a:srgbClr val="E6F2EA"/>
+          </a:solidFill>
+          <a:ln w="12700">
+            <a:solidFill>
+              <a:srgbClr val="E6F2EA"/>
+            </a:solidFill>
+            <a:prstDash val="solid"/>
+          </a:ln>
+        </p:spPr>
+      </p:sp>
+      <p:sp>
+        <p:nvSpPr>
+          <p:cNvPr id="19" name="Text 17"/>
+          <p:cNvSpPr txBox="1"/>
+          <p:nvPr/>
+        </p:nvSpPr>
+        <p:spPr>
+          <a:xfrm>
+            <a:off x="3675888" y="1783080"/>
+            <a:ext cx="1792224" cy="329184"/>
+          </a:xfrm>
+          <a:prstGeom prst="rect">
+            <a:avLst/>
+          </a:prstGeom>
+          <a:noFill/>
+          <a:ln/>
+        </p:spPr>
+        <p:txBody>
+          <a:bodyPr wrap="square" lIns="0" tIns="0" rIns="0" bIns="0" rtlCol="0" anchor="ctr"/>
+          <a:lstStyle/>
+          <a:p>
+            <a:pPr algn="ctr" indent="0" marL="0">
+              <a:buNone/>
+            </a:pPr>
+            <a:r>
+              <a:rPr lang="en-US" sz="850" b="1" dirty="0">
+                <a:solidFill>
+                  <a:srgbClr val="2E7D4F"/>
+                </a:solidFill>
+                <a:latin typeface="Arial" pitchFamily="34" charset="0"/>
+                <a:ea typeface="Arial" pitchFamily="34" charset="-122"/>
+                <a:cs typeface="Arial" pitchFamily="34" charset="-120"/>
+              </a:rPr>
+              <a:t>⟵ plan i postęp, co tydzień ⟶</a:t>
+            </a:r>
+            <a:endParaRPr lang="en-US" sz="850" dirty="0"/>
+          </a:p>
+        </p:txBody>
+      </p:sp>
+      <p:sp>
+        <p:nvSpPr>
+          <p:cNvPr id="20" name="arimr1"/>
+          <p:cNvSpPr/>
+          <p:nvPr/>
+        </p:nvSpPr>
+        <p:spPr>
+          <a:xfrm>
+            <a:off x="5532120" y="1783080"/>
+            <a:ext cx="3154680" cy="329184"/>
+          </a:xfrm>
+          <a:prstGeom prst="roundRect">
+            <a:avLst>
+              <a:gd name="adj" fmla="val 13889"/>
+            </a:avLst>
+          </a:prstGeom>
+          <a:solidFill>
+            <a:srgbClr val="EAF1F8"/>
+          </a:solidFill>
+          <a:ln w="12700">
+            <a:solidFill>
+              <a:srgbClr val="2E5F8A"/>
+            </a:solidFill>
+            <a:prstDash val="solid"/>
+          </a:ln>
+        </p:spPr>
+      </p:sp>
+      <p:sp>
+        <p:nvSpPr>
+          <p:cNvPr id="21" name="Text 19"/>
+          <p:cNvSpPr txBox="1"/>
+          <p:nvPr/>
+        </p:nvSpPr>
+        <p:spPr>
+          <a:xfrm>
+            <a:off x="5641848" y="1783080"/>
+            <a:ext cx="2971800" cy="329184"/>
+          </a:xfrm>
+          <a:prstGeom prst="rect">
+            <a:avLst/>
+          </a:prstGeom>
+          <a:noFill/>
+          <a:ln/>
+        </p:spPr>
+        <p:txBody>
+          <a:bodyPr wrap="square" lIns="0" tIns="0" rIns="0" bIns="0" rtlCol="0" anchor="ctr"/>
+          <a:lstStyle/>
+          <a:p>
+            <a:pPr indent="0" marL="0">
+              <a:buNone/>
+            </a:pPr>
+            <a:r>
+              <a:rPr lang="en-US" sz="950" b="1" dirty="0">
+                <a:solidFill>
+                  <a:srgbClr val="2B2B2B"/>
+                </a:solidFill>
+                <a:latin typeface="Arial" pitchFamily="34" charset="0"/>
+                <a:ea typeface="Arial" pitchFamily="34" charset="-122"/>
+                <a:cs typeface="Arial" pitchFamily="34" charset="-120"/>
+              </a:rPr>
+              <a:t>Koordynator: </a:t>
+            </a:r>
+            <a:pPr indent="0" marL="0">
+              <a:buNone/>
+            </a:pPr>
+            <a:r>
+              <a:rPr lang="en-US" sz="950" dirty="0">
+                <a:solidFill>
+                  <a:srgbClr val="2B2B2B"/>
+                </a:solidFill>
+                <a:latin typeface="Arial" pitchFamily="34" charset="0"/>
+                <a:ea typeface="Arial" pitchFamily="34" charset="-122"/>
+                <a:cs typeface="Arial" pitchFamily="34" charset="-120"/>
+              </a:rPr>
+              <a:t>koordynator projektu ARiMR</a:t>
+            </a:r>
+            <a:endParaRPr lang="en-US" sz="950" dirty="0"/>
+          </a:p>
+        </p:txBody>
+      </p:sp>
+      <p:sp>
+        <p:nvSpPr>
+          <p:cNvPr id="22" name="nasi2"/>
+          <p:cNvSpPr/>
+          <p:nvPr/>
+        </p:nvSpPr>
+        <p:spPr>
+          <a:xfrm>
+            <a:off x="457200" y="2176272"/>
+            <a:ext cx="3154680" cy="329184"/>
+          </a:xfrm>
+          <a:prstGeom prst="roundRect">
+            <a:avLst>
+              <a:gd name="adj" fmla="val 13889"/>
+            </a:avLst>
+          </a:prstGeom>
+          <a:solidFill>
+            <a:srgbClr val="FFFFFF"/>
+          </a:solidFill>
+          <a:ln w="12700">
+            <a:solidFill>
+              <a:srgbClr val="2B2B2B"/>
+            </a:solidFill>
+            <a:prstDash val="solid"/>
+          </a:ln>
+        </p:spPr>
+      </p:sp>
+      <p:sp>
+        <p:nvSpPr>
+          <p:cNvPr id="23" name="Text 21"/>
+          <p:cNvSpPr txBox="1"/>
+          <p:nvPr/>
+        </p:nvSpPr>
+        <p:spPr>
+          <a:xfrm>
+            <a:off x="566928" y="2176272"/>
+            <a:ext cx="2971800" cy="329184"/>
+          </a:xfrm>
+          <a:prstGeom prst="rect">
+            <a:avLst/>
+          </a:prstGeom>
+          <a:noFill/>
+          <a:ln/>
+        </p:spPr>
+        <p:txBody>
+          <a:bodyPr wrap="square" lIns="0" tIns="0" rIns="0" bIns="0" rtlCol="0" anchor="ctr"/>
+          <a:lstStyle/>
+          <a:p>
+            <a:pPr indent="0" marL="0">
+              <a:buNone/>
+            </a:pPr>
+            <a:r>
+              <a:rPr lang="en-US" sz="950" b="1" dirty="0">
+                <a:solidFill>
+                  <a:srgbClr val="2B2B2B"/>
+                </a:solidFill>
+                <a:latin typeface="Arial" pitchFamily="34" charset="0"/>
+                <a:ea typeface="Arial" pitchFamily="34" charset="-122"/>
+                <a:cs typeface="Arial" pitchFamily="34" charset="-120"/>
+              </a:rPr>
+              <a:t>Technika: </a:t>
+            </a:r>
+            <a:pPr indent="0" marL="0">
+              <a:buNone/>
+            </a:pPr>
+            <a:r>
+              <a:rPr lang="en-US" sz="950" dirty="0">
+                <a:solidFill>
+                  <a:srgbClr val="2B2B2B"/>
+                </a:solidFill>
+                <a:latin typeface="Arial" pitchFamily="34" charset="0"/>
+                <a:ea typeface="Arial" pitchFamily="34" charset="-122"/>
+                <a:cs typeface="Arial" pitchFamily="34" charset="-120"/>
+              </a:rPr>
+              <a:t>architekt + 2 programistów</a:t>
+            </a:r>
+            <a:endParaRPr lang="en-US" sz="950" dirty="0"/>
+          </a:p>
+        </p:txBody>
+      </p:sp>
+      <p:sp>
+        <p:nvSpPr>
+          <p:cNvPr id="24" name="wspolnie2"/>
+          <p:cNvSpPr/>
+          <p:nvPr/>
+        </p:nvSpPr>
+        <p:spPr>
+          <a:xfrm>
+            <a:off x="3749040" y="2176272"/>
+            <a:ext cx="1645920" cy="329184"/>
+          </a:xfrm>
+          <a:prstGeom prst="roundRect">
+            <a:avLst>
+              <a:gd name="adj" fmla="val 13889"/>
+            </a:avLst>
+          </a:prstGeom>
+          <a:solidFill>
+            <a:srgbClr val="E6F2EA"/>
+          </a:solidFill>
+          <a:ln w="12700">
+            <a:solidFill>
+              <a:srgbClr val="E6F2EA"/>
+            </a:solidFill>
+            <a:prstDash val="solid"/>
+          </a:ln>
+        </p:spPr>
+      </p:sp>
+      <p:sp>
+        <p:nvSpPr>
+          <p:cNvPr id="25" name="Text 23"/>
+          <p:cNvSpPr txBox="1"/>
+          <p:nvPr/>
+        </p:nvSpPr>
+        <p:spPr>
+          <a:xfrm>
+            <a:off x="3675888" y="2176272"/>
+            <a:ext cx="1792224" cy="329184"/>
+          </a:xfrm>
+          <a:prstGeom prst="rect">
+            <a:avLst/>
+          </a:prstGeom>
+          <a:noFill/>
+          <a:ln/>
+        </p:spPr>
+        <p:txBody>
+          <a:bodyPr wrap="square" lIns="0" tIns="0" rIns="0" bIns="0" rtlCol="0" anchor="ctr"/>
+          <a:lstStyle/>
+          <a:p>
+            <a:pPr algn="ctr" indent="0" marL="0">
+              <a:buNone/>
+            </a:pPr>
+            <a:r>
+              <a:rPr lang="en-US" sz="850" b="1" dirty="0">
+                <a:solidFill>
+                  <a:srgbClr val="2E7D4F"/>
+                </a:solidFill>
+                <a:latin typeface="Arial" pitchFamily="34" charset="0"/>
+                <a:ea typeface="Arial" pitchFamily="34" charset="-122"/>
+                <a:cs typeface="Arial" pitchFamily="34" charset="-120"/>
+              </a:rPr>
+              <a:t>⟵ opis API i testy ⟶</a:t>
+            </a:r>
+            <a:endParaRPr lang="en-US" sz="850" dirty="0"/>
+          </a:p>
+        </p:txBody>
+      </p:sp>
+      <p:sp>
+        <p:nvSpPr>
+          <p:cNvPr id="26" name="arimr2"/>
+          <p:cNvSpPr/>
+          <p:nvPr/>
+        </p:nvSpPr>
+        <p:spPr>
+          <a:xfrm>
+            <a:off x="5532120" y="2176272"/>
+            <a:ext cx="3154680" cy="329184"/>
+          </a:xfrm>
+          <a:prstGeom prst="roundRect">
+            <a:avLst>
+              <a:gd name="adj" fmla="val 13889"/>
+            </a:avLst>
+          </a:prstGeom>
+          <a:solidFill>
+            <a:srgbClr val="EAF1F8"/>
+          </a:solidFill>
+          <a:ln w="12700">
+            <a:solidFill>
+              <a:srgbClr val="2E5F8A"/>
+            </a:solidFill>
+            <a:prstDash val="solid"/>
+          </a:ln>
+        </p:spPr>
+      </p:sp>
+      <p:sp>
+        <p:nvSpPr>
+          <p:cNvPr id="27" name="Text 25"/>
+          <p:cNvSpPr txBox="1"/>
+          <p:nvPr/>
+        </p:nvSpPr>
+        <p:spPr>
+          <a:xfrm>
+            <a:off x="5641848" y="2176272"/>
+            <a:ext cx="2971800" cy="329184"/>
+          </a:xfrm>
+          <a:prstGeom prst="rect">
+            <a:avLst/>
+          </a:prstGeom>
+          <a:noFill/>
+          <a:ln/>
+        </p:spPr>
+        <p:txBody>
+          <a:bodyPr wrap="square" lIns="0" tIns="0" rIns="0" bIns="0" rtlCol="0" anchor="ctr"/>
+          <a:lstStyle/>
+          <a:p>
+            <a:pPr indent="0" marL="0">
+              <a:buNone/>
+            </a:pPr>
+            <a:r>
+              <a:rPr lang="en-US" sz="950" b="1" dirty="0">
+                <a:solidFill>
+                  <a:srgbClr val="2B2B2B"/>
+                </a:solidFill>
+                <a:latin typeface="Arial" pitchFamily="34" charset="0"/>
+                <a:ea typeface="Arial" pitchFamily="34" charset="-122"/>
+                <a:cs typeface="Arial" pitchFamily="34" charset="-120"/>
+              </a:rPr>
+              <a:t>Technika: </a:t>
+            </a:r>
+            <a:pPr indent="0" marL="0">
+              <a:buNone/>
+            </a:pPr>
+            <a:r>
+              <a:rPr lang="en-US" sz="950" dirty="0">
+                <a:solidFill>
+                  <a:srgbClr val="2B2B2B"/>
+                </a:solidFill>
+                <a:latin typeface="Arial" pitchFamily="34" charset="0"/>
+                <a:ea typeface="Arial" pitchFamily="34" charset="-122"/>
+                <a:cs typeface="Arial" pitchFamily="34" charset="-120"/>
+              </a:rPr>
+              <a:t>opiekun systemu + środowisko testowe</a:t>
+            </a:r>
+            <a:endParaRPr lang="en-US" sz="950" dirty="0"/>
+          </a:p>
+        </p:txBody>
+      </p:sp>
+      <p:sp>
+        <p:nvSpPr>
+          <p:cNvPr id="28" name="nasi3"/>
+          <p:cNvSpPr/>
+          <p:nvPr/>
+        </p:nvSpPr>
+        <p:spPr>
+          <a:xfrm>
+            <a:off x="457200" y="2569464"/>
+            <a:ext cx="3154680" cy="329184"/>
+          </a:xfrm>
+          <a:prstGeom prst="roundRect">
+            <a:avLst>
+              <a:gd name="adj" fmla="val 13889"/>
+            </a:avLst>
+          </a:prstGeom>
+          <a:solidFill>
+            <a:srgbClr val="FFFFFF"/>
+          </a:solidFill>
+          <a:ln w="12700">
+            <a:solidFill>
+              <a:srgbClr val="2B2B2B"/>
+            </a:solidFill>
+            <a:prstDash val="solid"/>
+          </a:ln>
+        </p:spPr>
+      </p:sp>
+      <p:sp>
+        <p:nvSpPr>
+          <p:cNvPr id="29" name="Text 27"/>
+          <p:cNvSpPr txBox="1"/>
+          <p:nvPr/>
+        </p:nvSpPr>
+        <p:spPr>
+          <a:xfrm>
+            <a:off x="566928" y="2569464"/>
+            <a:ext cx="2971800" cy="329184"/>
+          </a:xfrm>
+          <a:prstGeom prst="rect">
+            <a:avLst/>
+          </a:prstGeom>
+          <a:noFill/>
+          <a:ln/>
+        </p:spPr>
+        <p:txBody>
+          <a:bodyPr wrap="square" lIns="0" tIns="0" rIns="0" bIns="0" rtlCol="0" anchor="ctr"/>
+          <a:lstStyle/>
+          <a:p>
+            <a:pPr indent="0" marL="0">
+              <a:buNone/>
+            </a:pPr>
+            <a:r>
+              <a:rPr lang="en-US" sz="950" b="1" dirty="0">
+                <a:solidFill>
+                  <a:srgbClr val="2B2B2B"/>
+                </a:solidFill>
+                <a:latin typeface="Arial" pitchFamily="34" charset="0"/>
+                <a:ea typeface="Arial" pitchFamily="34" charset="-122"/>
+                <a:cs typeface="Arial" pitchFamily="34" charset="-120"/>
+              </a:rPr>
+              <a:t>Prawo i RODO: </a:t>
+            </a:r>
+            <a:pPr indent="0" marL="0">
+              <a:buNone/>
+            </a:pPr>
+            <a:r>
+              <a:rPr lang="en-US" sz="950" dirty="0">
+                <a:solidFill>
+                  <a:srgbClr val="2B2B2B"/>
+                </a:solidFill>
+                <a:latin typeface="Arial" pitchFamily="34" charset="0"/>
+                <a:ea typeface="Arial" pitchFamily="34" charset="-122"/>
+                <a:cs typeface="Arial" pitchFamily="34" charset="-120"/>
+              </a:rPr>
+              <a:t>prawnik + inspektor danych</a:t>
+            </a:r>
+            <a:endParaRPr lang="en-US" sz="950" dirty="0"/>
+          </a:p>
+        </p:txBody>
+      </p:sp>
+      <p:sp>
+        <p:nvSpPr>
+          <p:cNvPr id="30" name="wspolnie3"/>
+          <p:cNvSpPr/>
+          <p:nvPr/>
+        </p:nvSpPr>
+        <p:spPr>
+          <a:xfrm>
+            <a:off x="3749040" y="2569464"/>
+            <a:ext cx="1645920" cy="329184"/>
+          </a:xfrm>
+          <a:prstGeom prst="roundRect">
+            <a:avLst>
+              <a:gd name="adj" fmla="val 13889"/>
+            </a:avLst>
+          </a:prstGeom>
+          <a:solidFill>
+            <a:srgbClr val="E6F2EA"/>
+          </a:solidFill>
+          <a:ln w="12700">
+            <a:solidFill>
+              <a:srgbClr val="E6F2EA"/>
+            </a:solidFill>
+            <a:prstDash val="solid"/>
+          </a:ln>
+        </p:spPr>
+      </p:sp>
+      <p:sp>
+        <p:nvSpPr>
+          <p:cNvPr id="31" name="Text 29"/>
+          <p:cNvSpPr txBox="1"/>
+          <p:nvPr/>
+        </p:nvSpPr>
+        <p:spPr>
+          <a:xfrm>
+            <a:off x="3675888" y="2569464"/>
+            <a:ext cx="1792224" cy="329184"/>
+          </a:xfrm>
+          <a:prstGeom prst="rect">
+            <a:avLst/>
+          </a:prstGeom>
+          <a:noFill/>
+          <a:ln/>
+        </p:spPr>
+        <p:txBody>
+          <a:bodyPr wrap="square" lIns="0" tIns="0" rIns="0" bIns="0" rtlCol="0" anchor="ctr"/>
+          <a:lstStyle/>
+          <a:p>
+            <a:pPr algn="ctr" indent="0" marL="0">
+              <a:buNone/>
+            </a:pPr>
+            <a:r>
+              <a:rPr lang="en-US" sz="850" b="1" dirty="0">
+                <a:solidFill>
+                  <a:srgbClr val="2E7D4F"/>
+                </a:solidFill>
+                <a:latin typeface="Arial" pitchFamily="34" charset="0"/>
+                <a:ea typeface="Arial" pitchFamily="34" charset="-122"/>
+                <a:cs typeface="Arial" pitchFamily="34" charset="-120"/>
+              </a:rPr>
+              <a:t>⟵ zgoda i umowa o danych ⟶</a:t>
+            </a:r>
+            <a:endParaRPr lang="en-US" sz="850" dirty="0"/>
+          </a:p>
+        </p:txBody>
+      </p:sp>
+      <p:sp>
+        <p:nvSpPr>
+          <p:cNvPr id="32" name="arimr3"/>
+          <p:cNvSpPr/>
+          <p:nvPr/>
+        </p:nvSpPr>
+        <p:spPr>
+          <a:xfrm>
+            <a:off x="5532120" y="2569464"/>
+            <a:ext cx="3154680" cy="329184"/>
+          </a:xfrm>
+          <a:prstGeom prst="roundRect">
+            <a:avLst>
+              <a:gd name="adj" fmla="val 13889"/>
+            </a:avLst>
+          </a:prstGeom>
+          <a:solidFill>
+            <a:srgbClr val="EAF1F8"/>
+          </a:solidFill>
+          <a:ln w="12700">
+            <a:solidFill>
+              <a:srgbClr val="2E5F8A"/>
+            </a:solidFill>
+            <a:prstDash val="solid"/>
+          </a:ln>
+        </p:spPr>
+      </p:sp>
+      <p:sp>
+        <p:nvSpPr>
+          <p:cNvPr id="33" name="Text 31"/>
+          <p:cNvSpPr txBox="1"/>
+          <p:nvPr/>
+        </p:nvSpPr>
+        <p:spPr>
+          <a:xfrm>
+            <a:off x="5641848" y="2569464"/>
+            <a:ext cx="2971800" cy="329184"/>
+          </a:xfrm>
+          <a:prstGeom prst="rect">
+            <a:avLst/>
+          </a:prstGeom>
+          <a:noFill/>
+          <a:ln/>
+        </p:spPr>
+        <p:txBody>
+          <a:bodyPr wrap="square" lIns="0" tIns="0" rIns="0" bIns="0" rtlCol="0" anchor="ctr"/>
+          <a:lstStyle/>
+          <a:p>
+            <a:pPr indent="0" marL="0">
+              <a:buNone/>
+            </a:pPr>
+            <a:r>
+              <a:rPr lang="en-US" sz="950" b="1" dirty="0">
+                <a:solidFill>
+                  <a:srgbClr val="2B2B2B"/>
+                </a:solidFill>
+                <a:latin typeface="Arial" pitchFamily="34" charset="0"/>
+                <a:ea typeface="Arial" pitchFamily="34" charset="-122"/>
+                <a:cs typeface="Arial" pitchFamily="34" charset="-120"/>
+              </a:rPr>
+              <a:t>Prawo i RODO: </a:t>
+            </a:r>
+            <a:pPr indent="0" marL="0">
+              <a:buNone/>
+            </a:pPr>
+            <a:r>
+              <a:rPr lang="en-US" sz="950" dirty="0">
+                <a:solidFill>
+                  <a:srgbClr val="2B2B2B"/>
+                </a:solidFill>
+                <a:latin typeface="Arial" pitchFamily="34" charset="0"/>
+                <a:ea typeface="Arial" pitchFamily="34" charset="-122"/>
+                <a:cs typeface="Arial" pitchFamily="34" charset="-120"/>
+              </a:rPr>
+              <a:t>prawnik + inspektor danych</a:t>
+            </a:r>
+            <a:endParaRPr lang="en-US" sz="950" dirty="0"/>
+          </a:p>
+        </p:txBody>
+      </p:sp>
+      <p:sp>
+        <p:nvSpPr>
+          <p:cNvPr id="34" name="nasi4"/>
+          <p:cNvSpPr/>
+          <p:nvPr/>
+        </p:nvSpPr>
+        <p:spPr>
+          <a:xfrm>
+            <a:off x="457200" y="2962656"/>
+            <a:ext cx="3154680" cy="329184"/>
+          </a:xfrm>
+          <a:prstGeom prst="roundRect">
+            <a:avLst>
+              <a:gd name="adj" fmla="val 13889"/>
+            </a:avLst>
+          </a:prstGeom>
+          <a:solidFill>
+            <a:srgbClr val="FFFFFF"/>
+          </a:solidFill>
+          <a:ln w="12700">
+            <a:solidFill>
+              <a:srgbClr val="2B2B2B"/>
+            </a:solidFill>
+            <a:prstDash val="solid"/>
+          </a:ln>
+        </p:spPr>
+      </p:sp>
+      <p:sp>
+        <p:nvSpPr>
+          <p:cNvPr id="35" name="Text 33"/>
+          <p:cNvSpPr txBox="1"/>
+          <p:nvPr/>
+        </p:nvSpPr>
+        <p:spPr>
+          <a:xfrm>
+            <a:off x="566928" y="2962656"/>
+            <a:ext cx="2971800" cy="329184"/>
+          </a:xfrm>
+          <a:prstGeom prst="rect">
+            <a:avLst/>
+          </a:prstGeom>
+          <a:noFill/>
+          <a:ln/>
+        </p:spPr>
+        <p:txBody>
+          <a:bodyPr wrap="square" lIns="0" tIns="0" rIns="0" bIns="0" rtlCol="0" anchor="ctr"/>
+          <a:lstStyle/>
+          <a:p>
+            <a:pPr indent="0" marL="0">
+              <a:buNone/>
+            </a:pPr>
+            <a:r>
+              <a:rPr lang="en-US" sz="950" b="1" dirty="0">
+                <a:solidFill>
+                  <a:srgbClr val="2B2B2B"/>
+                </a:solidFill>
+                <a:latin typeface="Arial" pitchFamily="34" charset="0"/>
+                <a:ea typeface="Arial" pitchFamily="34" charset="-122"/>
+                <a:cs typeface="Arial" pitchFamily="34" charset="-120"/>
+              </a:rPr>
+              <a:t>Rolnicy: </a:t>
+            </a:r>
+            <a:pPr indent="0" marL="0">
+              <a:buNone/>
+            </a:pPr>
+            <a:r>
+              <a:rPr lang="en-US" sz="950" dirty="0">
+                <a:solidFill>
+                  <a:srgbClr val="2B2B2B"/>
+                </a:solidFill>
+                <a:latin typeface="Arial" pitchFamily="34" charset="0"/>
+                <a:ea typeface="Arial" pitchFamily="34" charset="-122"/>
+                <a:cs typeface="Arial" pitchFamily="34" charset="-120"/>
+              </a:rPr>
+              <a:t>koordynator agronomów</a:t>
+            </a:r>
+            <a:endParaRPr lang="en-US" sz="950" dirty="0"/>
+          </a:p>
+        </p:txBody>
+      </p:sp>
+      <p:sp>
+        <p:nvSpPr>
+          <p:cNvPr id="36" name="wspolnie4"/>
+          <p:cNvSpPr/>
+          <p:nvPr/>
+        </p:nvSpPr>
+        <p:spPr>
+          <a:xfrm>
+            <a:off x="3749040" y="2962656"/>
+            <a:ext cx="1645920" cy="329184"/>
+          </a:xfrm>
+          <a:prstGeom prst="roundRect">
+            <a:avLst>
+              <a:gd name="adj" fmla="val 13889"/>
+            </a:avLst>
+          </a:prstGeom>
+          <a:solidFill>
+            <a:srgbClr val="E6F2EA"/>
+          </a:solidFill>
+          <a:ln w="12700">
+            <a:solidFill>
+              <a:srgbClr val="E6F2EA"/>
+            </a:solidFill>
+            <a:prstDash val="solid"/>
+          </a:ln>
+        </p:spPr>
+      </p:sp>
+      <p:sp>
+        <p:nvSpPr>
+          <p:cNvPr id="37" name="Text 35"/>
+          <p:cNvSpPr txBox="1"/>
+          <p:nvPr/>
+        </p:nvSpPr>
+        <p:spPr>
+          <a:xfrm>
+            <a:off x="3675888" y="2962656"/>
+            <a:ext cx="1792224" cy="329184"/>
+          </a:xfrm>
+          <a:prstGeom prst="rect">
+            <a:avLst/>
+          </a:prstGeom>
+          <a:noFill/>
+          <a:ln/>
+        </p:spPr>
+        <p:txBody>
+          <a:bodyPr wrap="square" lIns="0" tIns="0" rIns="0" bIns="0" rtlCol="0" anchor="ctr"/>
+          <a:lstStyle/>
+          <a:p>
+            <a:pPr algn="ctr" indent="0" marL="0">
+              <a:buNone/>
+            </a:pPr>
+            <a:r>
+              <a:rPr lang="en-US" sz="850" b="1" dirty="0">
+                <a:solidFill>
+                  <a:srgbClr val="2E7D4F"/>
+                </a:solidFill>
+                <a:latin typeface="Arial" pitchFamily="34" charset="0"/>
+                <a:ea typeface="Arial" pitchFamily="34" charset="-122"/>
+                <a:cs typeface="Arial" pitchFamily="34" charset="-120"/>
+              </a:rPr>
+              <a:t>⟵ nabór rolników ⟶</a:t>
+            </a:r>
+            <a:endParaRPr lang="en-US" sz="850" dirty="0"/>
+          </a:p>
+        </p:txBody>
+      </p:sp>
+      <p:sp>
+        <p:nvSpPr>
+          <p:cNvPr id="38" name="arimr4"/>
+          <p:cNvSpPr/>
+          <p:nvPr/>
+        </p:nvSpPr>
+        <p:spPr>
+          <a:xfrm>
+            <a:off x="5532120" y="2962656"/>
+            <a:ext cx="3154680" cy="329184"/>
+          </a:xfrm>
+          <a:prstGeom prst="roundRect">
+            <a:avLst>
+              <a:gd name="adj" fmla="val 13889"/>
+            </a:avLst>
+          </a:prstGeom>
+          <a:solidFill>
+            <a:srgbClr val="EAF1F8"/>
+          </a:solidFill>
+          <a:ln w="12700">
+            <a:solidFill>
+              <a:srgbClr val="2E5F8A"/>
+            </a:solidFill>
+            <a:prstDash val="solid"/>
+          </a:ln>
+        </p:spPr>
+      </p:sp>
+      <p:sp>
+        <p:nvSpPr>
+          <p:cNvPr id="39" name="Text 37"/>
+          <p:cNvSpPr txBox="1"/>
+          <p:nvPr/>
+        </p:nvSpPr>
+        <p:spPr>
+          <a:xfrm>
+            <a:off x="5641848" y="2962656"/>
+            <a:ext cx="2971800" cy="329184"/>
+          </a:xfrm>
+          <a:prstGeom prst="rect">
+            <a:avLst/>
+          </a:prstGeom>
+          <a:noFill/>
+          <a:ln/>
+        </p:spPr>
+        <p:txBody>
+          <a:bodyPr wrap="square" lIns="0" tIns="0" rIns="0" bIns="0" rtlCol="0" anchor="ctr"/>
+          <a:lstStyle/>
+          <a:p>
+            <a:pPr indent="0" marL="0">
+              <a:buNone/>
+            </a:pPr>
+            <a:r>
+              <a:rPr lang="en-US" sz="950" b="1" dirty="0">
+                <a:solidFill>
+                  <a:srgbClr val="2B2B2B"/>
+                </a:solidFill>
+                <a:latin typeface="Arial" pitchFamily="34" charset="0"/>
+                <a:ea typeface="Arial" pitchFamily="34" charset="-122"/>
+                <a:cs typeface="Arial" pitchFamily="34" charset="-120"/>
+              </a:rPr>
+              <a:t>Rolnicy: </a:t>
+            </a:r>
+            <a:pPr indent="0" marL="0">
+              <a:buNone/>
+            </a:pPr>
+            <a:r>
+              <a:rPr lang="en-US" sz="950" dirty="0">
+                <a:solidFill>
+                  <a:srgbClr val="2B2B2B"/>
+                </a:solidFill>
+                <a:latin typeface="Arial" pitchFamily="34" charset="0"/>
+                <a:ea typeface="Arial" pitchFamily="34" charset="-122"/>
+                <a:cs typeface="Arial" pitchFamily="34" charset="-120"/>
+              </a:rPr>
+              <a:t>biuro w województwie pilotażowym</a:t>
+            </a:r>
+            <a:endParaRPr lang="en-US" sz="950" dirty="0"/>
+          </a:p>
+        </p:txBody>
+      </p:sp>
+      <p:sp>
+        <p:nvSpPr>
+          <p:cNvPr id="40" name="krok2_0"/>
+          <p:cNvSpPr/>
+          <p:nvPr/>
+        </p:nvSpPr>
+        <p:spPr>
+          <a:xfrm>
+            <a:off x="457200" y="3456432"/>
+            <a:ext cx="1536192" cy="896112"/>
+          </a:xfrm>
+          <a:prstGeom prst="roundRect">
+            <a:avLst>
+              <a:gd name="adj" fmla="val 6122"/>
+            </a:avLst>
+          </a:prstGeom>
+          <a:solidFill>
+            <a:srgbClr val="FFFFFF"/>
+          </a:solidFill>
+          <a:ln w="25400">
+            <a:solidFill>
+              <a:srgbClr val="2E7D4F"/>
+            </a:solidFill>
+            <a:prstDash val="solid"/>
+          </a:ln>
+          <a:effectLst>
+            <a:outerShdw sx="100000" sy="100000" kx="0" ky="0" algn="bl" rotWithShape="0" blurRad="50800" dist="19050" dir="5400000">
+              <a:srgbClr val="000000">
+                <a:alpha val="18000"/>
+              </a:srgbClr>
+            </a:outerShdw>
+          </a:effectLst>
+        </p:spPr>
+      </p:sp>
+      <p:sp>
+        <p:nvSpPr>
+          <p:cNvPr id="41" name="Text 39"/>
+          <p:cNvSpPr txBox="1"/>
+          <p:nvPr/>
+        </p:nvSpPr>
+        <p:spPr>
+          <a:xfrm>
+            <a:off x="548640" y="3529584"/>
+            <a:ext cx="1353312" cy="201168"/>
+          </a:xfrm>
+          <a:prstGeom prst="rect">
+            <a:avLst/>
+          </a:prstGeom>
+          <a:noFill/>
+          <a:ln/>
+        </p:spPr>
+        <p:txBody>
+          <a:bodyPr wrap="square" lIns="0" tIns="0" rIns="0" bIns="0" rtlCol="0" anchor="ctr"/>
+          <a:lstStyle/>
+          <a:p>
+            <a:pPr indent="0" marL="0">
+              <a:buNone/>
+            </a:pPr>
+            <a:r>
+              <a:rPr lang="en-US" sz="800" b="1" spc="100" kern="0" dirty="0">
+                <a:solidFill>
+                  <a:srgbClr val="2E7D4F"/>
+                </a:solidFill>
+                <a:latin typeface="Arial" pitchFamily="34" charset="0"/>
+                <a:ea typeface="Arial" pitchFamily="34" charset="-122"/>
+                <a:cs typeface="Arial" pitchFamily="34" charset="-120"/>
+              </a:rPr>
+              <a:t>DO 23.10.2026</a:t>
+            </a:r>
+            <a:endParaRPr lang="en-US" sz="800" dirty="0"/>
+          </a:p>
+        </p:txBody>
+      </p:sp>
+      <p:sp>
+        <p:nvSpPr>
+          <p:cNvPr id="42" name="Text 40"/>
+          <p:cNvSpPr txBox="1"/>
+          <p:nvPr/>
+        </p:nvSpPr>
+        <p:spPr>
+          <a:xfrm>
+            <a:off x="548640" y="3730752"/>
+            <a:ext cx="1353312" cy="219456"/>
+          </a:xfrm>
+          <a:prstGeom prst="rect">
+            <a:avLst/>
+          </a:prstGeom>
+          <a:noFill/>
+          <a:ln/>
+        </p:spPr>
+        <p:txBody>
+          <a:bodyPr wrap="square" lIns="0" tIns="0" rIns="0" bIns="0" rtlCol="0" anchor="ctr"/>
+          <a:lstStyle/>
+          <a:p>
+            <a:pPr indent="0" marL="0">
+              <a:buNone/>
+            </a:pPr>
+            <a:r>
+              <a:rPr lang="en-US" sz="1100" b="1" dirty="0">
+                <a:solidFill>
+                  <a:srgbClr val="2B2B2B"/>
+                </a:solidFill>
+                <a:latin typeface="Arial" pitchFamily="34" charset="0"/>
+                <a:ea typeface="Arial" pitchFamily="34" charset="-122"/>
+                <a:cs typeface="Arial" pitchFamily="34" charset="-120"/>
+              </a:rPr>
+              <a:t>1. Start</a:t>
+            </a:r>
+            <a:endParaRPr lang="en-US" sz="1100" dirty="0"/>
+          </a:p>
+        </p:txBody>
+      </p:sp>
+      <p:sp>
+        <p:nvSpPr>
+          <p:cNvPr id="43" name="Text 41"/>
+          <p:cNvSpPr txBox="1"/>
+          <p:nvPr/>
+        </p:nvSpPr>
+        <p:spPr>
+          <a:xfrm>
+            <a:off x="548640" y="3959352"/>
+            <a:ext cx="1353312" cy="347472"/>
+          </a:xfrm>
+          <a:prstGeom prst="rect">
+            <a:avLst/>
+          </a:prstGeom>
+          <a:noFill/>
+          <a:ln/>
+        </p:spPr>
+        <p:txBody>
+          <a:bodyPr wrap="square" lIns="0" tIns="0" rIns="0" bIns="0" rtlCol="0" anchor="t"/>
+          <a:lstStyle/>
+          <a:p>
+            <a:pPr indent="0" marL="0">
+              <a:buNone/>
+            </a:pPr>
+            <a:r>
+              <a:rPr lang="en-US" sz="850" dirty="0">
+                <a:solidFill>
+                  <a:srgbClr val="2B2B2B"/>
+                </a:solidFill>
+                <a:latin typeface="Arial" pitchFamily="34" charset="0"/>
+                <a:ea typeface="Arial" pitchFamily="34" charset="-122"/>
+                <a:cs typeface="Arial" pitchFamily="34" charset="-120"/>
+              </a:rPr>
+              <a:t>obie strony wskazują osoby, spotkanie startowe</a:t>
+            </a:r>
+            <a:endParaRPr lang="en-US" sz="850" dirty="0"/>
+          </a:p>
+        </p:txBody>
+      </p:sp>
+      <p:sp>
+        <p:nvSpPr>
+          <p:cNvPr id="44" name="krok2_1"/>
+          <p:cNvSpPr/>
+          <p:nvPr/>
+        </p:nvSpPr>
+        <p:spPr>
+          <a:xfrm>
+            <a:off x="2130552" y="3456432"/>
+            <a:ext cx="1536192" cy="896112"/>
+          </a:xfrm>
+          <a:prstGeom prst="roundRect">
+            <a:avLst>
+              <a:gd name="adj" fmla="val 6122"/>
+            </a:avLst>
+          </a:prstGeom>
+          <a:solidFill>
+            <a:srgbClr val="FFFFFF"/>
+          </a:solidFill>
+          <a:ln w="15875">
+            <a:solidFill>
+              <a:srgbClr val="2B2B2B"/>
+            </a:solidFill>
+            <a:prstDash val="solid"/>
+          </a:ln>
+          <a:effectLst>
+            <a:outerShdw sx="100000" sy="100000" kx="0" ky="0" algn="bl" rotWithShape="0" blurRad="50800" dist="19050" dir="5400000">
+              <a:srgbClr val="000000">
+                <a:alpha val="18000"/>
+              </a:srgbClr>
+            </a:outerShdw>
+          </a:effectLst>
+        </p:spPr>
+      </p:sp>
+      <p:sp>
+        <p:nvSpPr>
+          <p:cNvPr id="45" name="Text 43"/>
+          <p:cNvSpPr txBox="1"/>
+          <p:nvPr/>
+        </p:nvSpPr>
+        <p:spPr>
+          <a:xfrm>
+            <a:off x="2221992" y="3529584"/>
+            <a:ext cx="1353312" cy="201168"/>
+          </a:xfrm>
+          <a:prstGeom prst="rect">
+            <a:avLst/>
+          </a:prstGeom>
+          <a:noFill/>
+          <a:ln/>
+        </p:spPr>
+        <p:txBody>
+          <a:bodyPr wrap="square" lIns="0" tIns="0" rIns="0" bIns="0" rtlCol="0" anchor="ctr"/>
+          <a:lstStyle/>
+          <a:p>
+            <a:pPr indent="0" marL="0">
+              <a:buNone/>
+            </a:pPr>
+            <a:r>
+              <a:rPr lang="en-US" sz="800" b="1" spc="100" kern="0" dirty="0">
+                <a:solidFill>
+                  <a:srgbClr val="2E5F8A"/>
+                </a:solidFill>
+                <a:latin typeface="Arial" pitchFamily="34" charset="0"/>
+                <a:ea typeface="Arial" pitchFamily="34" charset="-122"/>
+                <a:cs typeface="Arial" pitchFamily="34" charset="-120"/>
+              </a:rPr>
+              <a:t>LISTOPAD</a:t>
+            </a:r>
+            <a:endParaRPr lang="en-US" sz="800" dirty="0"/>
+          </a:p>
+        </p:txBody>
+      </p:sp>
+      <p:sp>
+        <p:nvSpPr>
+          <p:cNvPr id="46" name="Text 44"/>
+          <p:cNvSpPr txBox="1"/>
+          <p:nvPr/>
+        </p:nvSpPr>
+        <p:spPr>
+          <a:xfrm>
+            <a:off x="2221992" y="3730752"/>
+            <a:ext cx="1353312" cy="219456"/>
+          </a:xfrm>
+          <a:prstGeom prst="rect">
+            <a:avLst/>
+          </a:prstGeom>
+          <a:noFill/>
+          <a:ln/>
+        </p:spPr>
+        <p:txBody>
+          <a:bodyPr wrap="square" lIns="0" tIns="0" rIns="0" bIns="0" rtlCol="0" anchor="ctr"/>
+          <a:lstStyle/>
+          <a:p>
+            <a:pPr indent="0" marL="0">
+              <a:buNone/>
+            </a:pPr>
+            <a:r>
+              <a:rPr lang="en-US" sz="1100" b="1" dirty="0">
+                <a:solidFill>
+                  <a:srgbClr val="2B2B2B"/>
+                </a:solidFill>
+                <a:latin typeface="Arial" pitchFamily="34" charset="0"/>
+                <a:ea typeface="Arial" pitchFamily="34" charset="-122"/>
+                <a:cs typeface="Arial" pitchFamily="34" charset="-120"/>
+              </a:rPr>
+              <a:t>2. Zgoda i dane</a:t>
+            </a:r>
+            <a:endParaRPr lang="en-US" sz="1100" dirty="0"/>
+          </a:p>
+        </p:txBody>
+      </p:sp>
+      <p:sp>
+        <p:nvSpPr>
+          <p:cNvPr id="47" name="Text 45"/>
+          <p:cNvSpPr txBox="1"/>
+          <p:nvPr/>
+        </p:nvSpPr>
+        <p:spPr>
+          <a:xfrm>
+            <a:off x="2221992" y="3959352"/>
+            <a:ext cx="1353312" cy="347472"/>
+          </a:xfrm>
+          <a:prstGeom prst="rect">
+            <a:avLst/>
+          </a:prstGeom>
+          <a:noFill/>
+          <a:ln/>
+        </p:spPr>
+        <p:txBody>
+          <a:bodyPr wrap="square" lIns="0" tIns="0" rIns="0" bIns="0" rtlCol="0" anchor="t"/>
+          <a:lstStyle/>
+          <a:p>
+            <a:pPr indent="0" marL="0">
+              <a:buNone/>
+            </a:pPr>
+            <a:r>
+              <a:rPr lang="en-US" sz="850" dirty="0">
+                <a:solidFill>
+                  <a:srgbClr val="2B2B2B"/>
+                </a:solidFill>
+                <a:latin typeface="Arial" pitchFamily="34" charset="0"/>
+                <a:ea typeface="Arial" pitchFamily="34" charset="-122"/>
+                <a:cs typeface="Arial" pitchFamily="34" charset="-120"/>
+              </a:rPr>
+              <a:t>zakres danych, treść zgody, umowa wykonawcza</a:t>
+            </a:r>
+            <a:endParaRPr lang="en-US" sz="850" dirty="0"/>
+          </a:p>
+        </p:txBody>
+      </p:sp>
+      <p:sp>
+        <p:nvSpPr>
+          <p:cNvPr id="48" name="krok2_2"/>
+          <p:cNvSpPr/>
+          <p:nvPr/>
+        </p:nvSpPr>
+        <p:spPr>
+          <a:xfrm>
+            <a:off x="3803904" y="3456432"/>
+            <a:ext cx="1536192" cy="896112"/>
+          </a:xfrm>
+          <a:prstGeom prst="roundRect">
+            <a:avLst>
+              <a:gd name="adj" fmla="val 6122"/>
+            </a:avLst>
+          </a:prstGeom>
+          <a:solidFill>
+            <a:srgbClr val="FFFFFF"/>
+          </a:solidFill>
+          <a:ln w="15875">
+            <a:solidFill>
+              <a:srgbClr val="2B2B2B"/>
+            </a:solidFill>
+            <a:prstDash val="solid"/>
+          </a:ln>
+          <a:effectLst>
+            <a:outerShdw sx="100000" sy="100000" kx="0" ky="0" algn="bl" rotWithShape="0" blurRad="50800" dist="19050" dir="5400000">
+              <a:srgbClr val="000000">
+                <a:alpha val="18000"/>
+              </a:srgbClr>
+            </a:outerShdw>
+          </a:effectLst>
+        </p:spPr>
+      </p:sp>
+      <p:sp>
+        <p:nvSpPr>
+          <p:cNvPr id="49" name="Text 47"/>
+          <p:cNvSpPr txBox="1"/>
+          <p:nvPr/>
+        </p:nvSpPr>
+        <p:spPr>
+          <a:xfrm>
+            <a:off x="3895344" y="3529584"/>
+            <a:ext cx="1353312" cy="201168"/>
+          </a:xfrm>
+          <a:prstGeom prst="rect">
+            <a:avLst/>
+          </a:prstGeom>
+          <a:noFill/>
+          <a:ln/>
+        </p:spPr>
+        <p:txBody>
+          <a:bodyPr wrap="square" lIns="0" tIns="0" rIns="0" bIns="0" rtlCol="0" anchor="ctr"/>
+          <a:lstStyle/>
+          <a:p>
+            <a:pPr indent="0" marL="0">
+              <a:buNone/>
+            </a:pPr>
+            <a:r>
+              <a:rPr lang="en-US" sz="800" b="1" spc="100" kern="0" dirty="0">
+                <a:solidFill>
+                  <a:srgbClr val="2E5F8A"/>
+                </a:solidFill>
+                <a:latin typeface="Arial" pitchFamily="34" charset="0"/>
+                <a:ea typeface="Arial" pitchFamily="34" charset="-122"/>
+                <a:cs typeface="Arial" pitchFamily="34" charset="-120"/>
+              </a:rPr>
+              <a:t>GRUDZIEŃ–STYCZEŃ</a:t>
+            </a:r>
+            <a:endParaRPr lang="en-US" sz="800" dirty="0"/>
+          </a:p>
+        </p:txBody>
+      </p:sp>
+      <p:sp>
+        <p:nvSpPr>
+          <p:cNvPr id="50" name="Text 48"/>
+          <p:cNvSpPr txBox="1"/>
+          <p:nvPr/>
+        </p:nvSpPr>
+        <p:spPr>
+          <a:xfrm>
+            <a:off x="3895344" y="3730752"/>
+            <a:ext cx="1353312" cy="219456"/>
+          </a:xfrm>
+          <a:prstGeom prst="rect">
+            <a:avLst/>
+          </a:prstGeom>
+          <a:noFill/>
+          <a:ln/>
+        </p:spPr>
+        <p:txBody>
+          <a:bodyPr wrap="square" lIns="0" tIns="0" rIns="0" bIns="0" rtlCol="0" anchor="ctr"/>
+          <a:lstStyle/>
+          <a:p>
+            <a:pPr indent="0" marL="0">
+              <a:buNone/>
+            </a:pPr>
+            <a:r>
+              <a:rPr lang="en-US" sz="1100" b="1" dirty="0">
+                <a:solidFill>
+                  <a:srgbClr val="2B2B2B"/>
+                </a:solidFill>
+                <a:latin typeface="Arial" pitchFamily="34" charset="0"/>
+                <a:ea typeface="Arial" pitchFamily="34" charset="-122"/>
+                <a:cs typeface="Arial" pitchFamily="34" charset="-120"/>
+              </a:rPr>
+              <a:t>3. API i testy</a:t>
+            </a:r>
+            <a:endParaRPr lang="en-US" sz="1100" dirty="0"/>
+          </a:p>
+        </p:txBody>
+      </p:sp>
+      <p:sp>
+        <p:nvSpPr>
+          <p:cNvPr id="51" name="Text 49"/>
+          <p:cNvSpPr txBox="1"/>
+          <p:nvPr/>
+        </p:nvSpPr>
+        <p:spPr>
+          <a:xfrm>
+            <a:off x="3895344" y="3959352"/>
+            <a:ext cx="1353312" cy="347472"/>
+          </a:xfrm>
+          <a:prstGeom prst="rect">
+            <a:avLst/>
+          </a:prstGeom>
+          <a:noFill/>
+          <a:ln/>
+        </p:spPr>
+        <p:txBody>
+          <a:bodyPr wrap="square" lIns="0" tIns="0" rIns="0" bIns="0" rtlCol="0" anchor="t"/>
+          <a:lstStyle/>
+          <a:p>
+            <a:pPr indent="0" marL="0">
+              <a:buNone/>
+            </a:pPr>
+            <a:r>
+              <a:rPr lang="en-US" sz="850" dirty="0">
+                <a:solidFill>
+                  <a:srgbClr val="2B2B2B"/>
+                </a:solidFill>
+                <a:latin typeface="Arial" pitchFamily="34" charset="0"/>
+                <a:ea typeface="Arial" pitchFamily="34" charset="-122"/>
+                <a:cs typeface="Arial" pitchFamily="34" charset="-120"/>
+              </a:rPr>
+              <a:t>opis usługi, testy na danych testowych</a:t>
+            </a:r>
+            <a:endParaRPr lang="en-US" sz="850" dirty="0"/>
+          </a:p>
+        </p:txBody>
+      </p:sp>
+      <p:sp>
+        <p:nvSpPr>
+          <p:cNvPr id="52" name="krok2_3"/>
+          <p:cNvSpPr/>
+          <p:nvPr/>
+        </p:nvSpPr>
+        <p:spPr>
+          <a:xfrm>
+            <a:off x="5477256" y="3456432"/>
+            <a:ext cx="1536192" cy="896112"/>
+          </a:xfrm>
+          <a:prstGeom prst="roundRect">
+            <a:avLst>
+              <a:gd name="adj" fmla="val 6122"/>
+            </a:avLst>
+          </a:prstGeom>
+          <a:solidFill>
+            <a:srgbClr val="FFFFFF"/>
+          </a:solidFill>
+          <a:ln w="15875">
+            <a:solidFill>
+              <a:srgbClr val="2B2B2B"/>
+            </a:solidFill>
+            <a:prstDash val="solid"/>
+          </a:ln>
+          <a:effectLst>
+            <a:outerShdw sx="100000" sy="100000" kx="0" ky="0" algn="bl" rotWithShape="0" blurRad="50800" dist="19050" dir="5400000">
+              <a:srgbClr val="000000">
+                <a:alpha val="18000"/>
+              </a:srgbClr>
+            </a:outerShdw>
+          </a:effectLst>
+        </p:spPr>
+      </p:sp>
+      <p:sp>
+        <p:nvSpPr>
+          <p:cNvPr id="53" name="Text 51"/>
+          <p:cNvSpPr txBox="1"/>
+          <p:nvPr/>
+        </p:nvSpPr>
+        <p:spPr>
+          <a:xfrm>
+            <a:off x="5568696" y="3529584"/>
+            <a:ext cx="1353312" cy="201168"/>
+          </a:xfrm>
+          <a:prstGeom prst="rect">
+            <a:avLst/>
+          </a:prstGeom>
+          <a:noFill/>
+          <a:ln/>
+        </p:spPr>
+        <p:txBody>
+          <a:bodyPr wrap="square" lIns="0" tIns="0" rIns="0" bIns="0" rtlCol="0" anchor="ctr"/>
+          <a:lstStyle/>
+          <a:p>
+            <a:pPr indent="0" marL="0">
+              <a:buNone/>
+            </a:pPr>
+            <a:r>
+              <a:rPr lang="en-US" sz="800" b="1" spc="100" kern="0" dirty="0">
+                <a:solidFill>
+                  <a:srgbClr val="2E5F8A"/>
+                </a:solidFill>
+                <a:latin typeface="Arial" pitchFamily="34" charset="0"/>
+                <a:ea typeface="Arial" pitchFamily="34" charset="-122"/>
+                <a:cs typeface="Arial" pitchFamily="34" charset="-120"/>
+              </a:rPr>
+              <a:t>LUTY–KWIECIEŃ 2027</a:t>
+            </a:r>
+            <a:endParaRPr lang="en-US" sz="800" dirty="0"/>
+          </a:p>
+        </p:txBody>
+      </p:sp>
+      <p:sp>
+        <p:nvSpPr>
+          <p:cNvPr id="54" name="Text 52"/>
+          <p:cNvSpPr txBox="1"/>
+          <p:nvPr/>
+        </p:nvSpPr>
+        <p:spPr>
+          <a:xfrm>
+            <a:off x="5568696" y="3730752"/>
+            <a:ext cx="1353312" cy="219456"/>
+          </a:xfrm>
+          <a:prstGeom prst="rect">
+            <a:avLst/>
+          </a:prstGeom>
+          <a:noFill/>
+          <a:ln/>
+        </p:spPr>
+        <p:txBody>
+          <a:bodyPr wrap="square" lIns="0" tIns="0" rIns="0" bIns="0" rtlCol="0" anchor="ctr"/>
+          <a:lstStyle/>
+          <a:p>
+            <a:pPr indent="0" marL="0">
+              <a:buNone/>
+            </a:pPr>
+            <a:r>
+              <a:rPr lang="en-US" sz="1100" b="1" dirty="0">
+                <a:solidFill>
+                  <a:srgbClr val="2B2B2B"/>
+                </a:solidFill>
+                <a:latin typeface="Arial" pitchFamily="34" charset="0"/>
+                <a:ea typeface="Arial" pitchFamily="34" charset="-122"/>
+                <a:cs typeface="Arial" pitchFamily="34" charset="-120"/>
+              </a:rPr>
+              <a:t>4. Pilotaż</a:t>
+            </a:r>
+            <a:endParaRPr lang="en-US" sz="1100" dirty="0"/>
+          </a:p>
+        </p:txBody>
+      </p:sp>
+      <p:sp>
+        <p:nvSpPr>
+          <p:cNvPr id="55" name="Text 53"/>
+          <p:cNvSpPr txBox="1"/>
+          <p:nvPr/>
+        </p:nvSpPr>
+        <p:spPr>
+          <a:xfrm>
+            <a:off x="5568696" y="3959352"/>
+            <a:ext cx="1353312" cy="347472"/>
+          </a:xfrm>
+          <a:prstGeom prst="rect">
+            <a:avLst/>
+          </a:prstGeom>
+          <a:noFill/>
+          <a:ln/>
+        </p:spPr>
+        <p:txBody>
+          <a:bodyPr wrap="square" lIns="0" tIns="0" rIns="0" bIns="0" rtlCol="0" anchor="t"/>
+          <a:lstStyle/>
+          <a:p>
+            <a:pPr indent="0" marL="0">
+              <a:buNone/>
+            </a:pPr>
+            <a:r>
+              <a:rPr lang="en-US" sz="850" dirty="0">
+                <a:solidFill>
+                  <a:srgbClr val="2B2B2B"/>
+                </a:solidFill>
+                <a:latin typeface="Arial" pitchFamily="34" charset="0"/>
+                <a:ea typeface="Arial" pitchFamily="34" charset="-122"/>
+                <a:cs typeface="Arial" pitchFamily="34" charset="-120"/>
+              </a:rPr>
+              <a:t>1 województwo, sezon wiosenny</a:t>
+            </a:r>
+            <a:endParaRPr lang="en-US" sz="850" dirty="0"/>
+          </a:p>
+        </p:txBody>
+      </p:sp>
+      <p:sp>
+        <p:nvSpPr>
+          <p:cNvPr id="56" name="krok2_4"/>
+          <p:cNvSpPr/>
+          <p:nvPr/>
+        </p:nvSpPr>
+        <p:spPr>
+          <a:xfrm>
+            <a:off x="7150608" y="3456432"/>
+            <a:ext cx="1536192" cy="896112"/>
+          </a:xfrm>
+          <a:prstGeom prst="roundRect">
+            <a:avLst>
+              <a:gd name="adj" fmla="val 6122"/>
+            </a:avLst>
+          </a:prstGeom>
+          <a:solidFill>
+            <a:srgbClr val="FFFFFF"/>
+          </a:solidFill>
+          <a:ln w="15875">
+            <a:solidFill>
+              <a:srgbClr val="2B2B2B"/>
+            </a:solidFill>
+            <a:prstDash val="solid"/>
+          </a:ln>
+          <a:effectLst>
+            <a:outerShdw sx="100000" sy="100000" kx="0" ky="0" algn="bl" rotWithShape="0" blurRad="50800" dist="19050" dir="5400000">
+              <a:srgbClr val="000000">
+                <a:alpha val="18000"/>
+              </a:srgbClr>
+            </a:outerShdw>
+          </a:effectLst>
+        </p:spPr>
+      </p:sp>
+      <p:sp>
+        <p:nvSpPr>
+          <p:cNvPr id="57" name="Text 55"/>
+          <p:cNvSpPr txBox="1"/>
+          <p:nvPr/>
+        </p:nvSpPr>
+        <p:spPr>
+          <a:xfrm>
+            <a:off x="7242048" y="3529584"/>
+            <a:ext cx="1353312" cy="201168"/>
+          </a:xfrm>
+          <a:prstGeom prst="rect">
+            <a:avLst/>
+          </a:prstGeom>
+          <a:noFill/>
+          <a:ln/>
+        </p:spPr>
+        <p:txBody>
+          <a:bodyPr wrap="square" lIns="0" tIns="0" rIns="0" bIns="0" rtlCol="0" anchor="ctr"/>
+          <a:lstStyle/>
+          <a:p>
+            <a:pPr indent="0" marL="0">
+              <a:buNone/>
+            </a:pPr>
+            <a:r>
+              <a:rPr lang="en-US" sz="800" b="1" spc="100" kern="0" dirty="0">
+                <a:solidFill>
+                  <a:srgbClr val="2E5F8A"/>
+                </a:solidFill>
+                <a:latin typeface="Arial" pitchFamily="34" charset="0"/>
+                <a:ea typeface="Arial" pitchFamily="34" charset="-122"/>
+                <a:cs typeface="Arial" pitchFamily="34" charset="-120"/>
+              </a:rPr>
+              <a:t>MAJ 2027</a:t>
+            </a:r>
+            <a:endParaRPr lang="en-US" sz="800" dirty="0"/>
+          </a:p>
+        </p:txBody>
+      </p:sp>
+      <p:sp>
+        <p:nvSpPr>
+          <p:cNvPr id="58" name="Text 56"/>
+          <p:cNvSpPr txBox="1"/>
+          <p:nvPr/>
+        </p:nvSpPr>
+        <p:spPr>
+          <a:xfrm>
+            <a:off x="7242048" y="3730752"/>
+            <a:ext cx="1353312" cy="219456"/>
+          </a:xfrm>
+          <a:prstGeom prst="rect">
+            <a:avLst/>
+          </a:prstGeom>
+          <a:noFill/>
+          <a:ln/>
+        </p:spPr>
+        <p:txBody>
+          <a:bodyPr wrap="square" lIns="0" tIns="0" rIns="0" bIns="0" rtlCol="0" anchor="ctr"/>
+          <a:lstStyle/>
+          <a:p>
+            <a:pPr indent="0" marL="0">
+              <a:buNone/>
+            </a:pPr>
+            <a:r>
+              <a:rPr lang="en-US" sz="1100" b="1" dirty="0">
+                <a:solidFill>
+                  <a:srgbClr val="2B2B2B"/>
+                </a:solidFill>
+                <a:latin typeface="Arial" pitchFamily="34" charset="0"/>
+                <a:ea typeface="Arial" pitchFamily="34" charset="-122"/>
+                <a:cs typeface="Arial" pitchFamily="34" charset="-120"/>
+              </a:rPr>
+              <a:t>5. Decyzja</a:t>
+            </a:r>
+            <a:endParaRPr lang="en-US" sz="1100" dirty="0"/>
+          </a:p>
+        </p:txBody>
+      </p:sp>
+      <p:sp>
+        <p:nvSpPr>
+          <p:cNvPr id="59" name="Text 57"/>
+          <p:cNvSpPr txBox="1"/>
+          <p:nvPr/>
+        </p:nvSpPr>
+        <p:spPr>
+          <a:xfrm>
+            <a:off x="7242048" y="3959352"/>
+            <a:ext cx="1353312" cy="347472"/>
+          </a:xfrm>
+          <a:prstGeom prst="rect">
+            <a:avLst/>
+          </a:prstGeom>
+          <a:noFill/>
+          <a:ln/>
+        </p:spPr>
+        <p:txBody>
+          <a:bodyPr wrap="square" lIns="0" tIns="0" rIns="0" bIns="0" rtlCol="0" anchor="t"/>
+          <a:lstStyle/>
+          <a:p>
+            <a:pPr indent="0" marL="0">
+              <a:buNone/>
+            </a:pPr>
+            <a:r>
+              <a:rPr lang="en-US" sz="850" dirty="0">
+                <a:solidFill>
+                  <a:srgbClr val="2B2B2B"/>
+                </a:solidFill>
+                <a:latin typeface="Arial" pitchFamily="34" charset="0"/>
+                <a:ea typeface="Arial" pitchFamily="34" charset="-122"/>
+                <a:cs typeface="Arial" pitchFamily="34" charset="-120"/>
+              </a:rPr>
+              <a:t>wyniki pilotażu, plan dla całego kraju</a:t>
+            </a:r>
+            <a:endParaRPr lang="en-US" sz="850" dirty="0"/>
+          </a:p>
+        </p:txBody>
+      </p:sp>
+      <p:sp>
+        <p:nvSpPr>
+          <p:cNvPr id="60" name="Shape 58"/>
+          <p:cNvSpPr/>
+          <p:nvPr/>
+        </p:nvSpPr>
+        <p:spPr>
+          <a:xfrm>
+            <a:off x="457200" y="4480560"/>
+            <a:ext cx="8229600" cy="438912"/>
+          </a:xfrm>
+          <a:prstGeom prst="roundRect">
+            <a:avLst>
+              <a:gd name="adj" fmla="val 10417"/>
+            </a:avLst>
+          </a:prstGeom>
+          <a:solidFill>
+            <a:srgbClr val="1F3A57">
+              <a:alpha val="92000"/>
+            </a:srgbClr>
+          </a:solidFill>
+          <a:ln w="12700">
+            <a:solidFill>
+              <a:srgbClr val="1F3A57"/>
+            </a:solidFill>
+            <a:prstDash val="solid"/>
+          </a:ln>
+        </p:spPr>
+      </p:sp>
+      <p:sp>
+        <p:nvSpPr>
+          <p:cNvPr id="61" name="Text 59"/>
+          <p:cNvSpPr txBox="1"/>
+          <p:nvPr/>
+        </p:nvSpPr>
+        <p:spPr>
+          <a:xfrm>
+            <a:off x="640080" y="4480560"/>
+            <a:ext cx="7955280" cy="438912"/>
+          </a:xfrm>
+          <a:prstGeom prst="rect">
+            <a:avLst/>
+          </a:prstGeom>
+          <a:noFill/>
+          <a:ln/>
+        </p:spPr>
+        <p:txBody>
+          <a:bodyPr wrap="square" lIns="0" tIns="0" rIns="0" bIns="0" rtlCol="0" anchor="ctr"/>
+          <a:lstStyle/>
+          <a:p>
+            <a:pPr indent="0" marL="0">
+              <a:buNone/>
+            </a:pPr>
+            <a:r>
+              <a:rPr lang="en-US" sz="1000" b="1" dirty="0">
+                <a:solidFill>
+                  <a:srgbClr val="FFFFFF"/>
+                </a:solidFill>
+                <a:latin typeface="Arial" pitchFamily="34" charset="0"/>
+                <a:ea typeface="Arial" pitchFamily="34" charset="-122"/>
+                <a:cs typeface="Arial" pitchFamily="34" charset="-120"/>
+              </a:rPr>
+              <a:t>Prosimy dziś ARiMR o: </a:t>
+            </a:r>
+            <a:pPr indent="0" marL="0">
+              <a:buNone/>
+            </a:pPr>
+            <a:r>
+              <a:rPr lang="en-US" sz="1000" dirty="0">
+                <a:solidFill>
+                  <a:srgbClr val="FFFFFF"/>
+                </a:solidFill>
+                <a:latin typeface="Arial" pitchFamily="34" charset="0"/>
+                <a:ea typeface="Arial" pitchFamily="34" charset="-122"/>
+                <a:cs typeface="Arial" pitchFamily="34" charset="-120"/>
+              </a:rPr>
+              <a:t>koordynatora i 5 osób do zespołu do 23.10, dokumentację systemu i dostęp testowy.</a:t>
             </a:r>
             <a:endParaRPr lang="en-US" sz="1000" dirty="0"/>
           </a:p>

</xml_diff>